<commit_message>
docs(presentation): refer to operations team
</commit_message>
<xml_diff>
--- a/docs/EOL_Tracker_Project_Overview.pptx
+++ b/docs/EOL_Tracker_Project_Overview.pptx
@@ -2,22 +2,22 @@
 <file path=ppt/presentation.xml><?xml version="1.0" encoding="utf-8"?>
 <p:presentation xmlns:p="http://schemas.openxmlformats.org/presentationml/2006/main">
   <p:sldMasterIdLst>
-    <p:sldMasterId xmlns:r="http://schemas.openxmlformats.org/officeDocument/2006/relationships" id="2147483648" r:id="R4f357f14663044dc"/>
+    <p:sldMasterId xmlns:r="http://schemas.openxmlformats.org/officeDocument/2006/relationships" id="2147483648" r:id="R825b90dd868c4766"/>
   </p:sldMasterIdLst>
   <p:notesMasterIdLst>
-    <p:notesMasterId xmlns:r="http://schemas.openxmlformats.org/officeDocument/2006/relationships" r:id="R5c9bb1a4020f444b"/>
+    <p:notesMasterId xmlns:r="http://schemas.openxmlformats.org/officeDocument/2006/relationships" r:id="R64d41fed89724688"/>
   </p:notesMasterIdLst>
   <p:sldIdLst>
-    <p:sldId xmlns:r="http://schemas.openxmlformats.org/officeDocument/2006/relationships" id="256" r:id="Rba0a5ea7aa6f4696"/>
-    <p:sldId xmlns:r="http://schemas.openxmlformats.org/officeDocument/2006/relationships" id="257" r:id="R6f78df94120c4ac2"/>
-    <p:sldId xmlns:r="http://schemas.openxmlformats.org/officeDocument/2006/relationships" id="258" r:id="R7b563c3fef124b4c"/>
-    <p:sldId xmlns:r="http://schemas.openxmlformats.org/officeDocument/2006/relationships" id="259" r:id="R7cb3b7087bfc410d"/>
-    <p:sldId xmlns:r="http://schemas.openxmlformats.org/officeDocument/2006/relationships" id="260" r:id="R788158a3e8464245"/>
-    <p:sldId xmlns:r="http://schemas.openxmlformats.org/officeDocument/2006/relationships" id="261" r:id="R5b656f93f175423f"/>
-    <p:sldId xmlns:r="http://schemas.openxmlformats.org/officeDocument/2006/relationships" id="262" r:id="R79559ed57f9346e5"/>
-    <p:sldId xmlns:r="http://schemas.openxmlformats.org/officeDocument/2006/relationships" id="263" r:id="R2c224ba0fb9346ba"/>
-    <p:sldId xmlns:r="http://schemas.openxmlformats.org/officeDocument/2006/relationships" id="264" r:id="R7e65d581aab34247"/>
-    <p:sldId xmlns:r="http://schemas.openxmlformats.org/officeDocument/2006/relationships" id="265" r:id="R1038be7768e9431f"/>
+    <p:sldId xmlns:r="http://schemas.openxmlformats.org/officeDocument/2006/relationships" id="256" r:id="R14b1f9ea3a104c2c"/>
+    <p:sldId xmlns:r="http://schemas.openxmlformats.org/officeDocument/2006/relationships" id="257" r:id="Rb2d70784b6b64aa9"/>
+    <p:sldId xmlns:r="http://schemas.openxmlformats.org/officeDocument/2006/relationships" id="258" r:id="Re00cc89c983f4e7e"/>
+    <p:sldId xmlns:r="http://schemas.openxmlformats.org/officeDocument/2006/relationships" id="259" r:id="Rdb10d187c53a49a7"/>
+    <p:sldId xmlns:r="http://schemas.openxmlformats.org/officeDocument/2006/relationships" id="260" r:id="R161238ca484248ca"/>
+    <p:sldId xmlns:r="http://schemas.openxmlformats.org/officeDocument/2006/relationships" id="261" r:id="R282ddf652c0b4de6"/>
+    <p:sldId xmlns:r="http://schemas.openxmlformats.org/officeDocument/2006/relationships" id="262" r:id="Rd690d3d316a94d9d"/>
+    <p:sldId xmlns:r="http://schemas.openxmlformats.org/officeDocument/2006/relationships" id="263" r:id="R77539b0fd1ce4089"/>
+    <p:sldId xmlns:r="http://schemas.openxmlformats.org/officeDocument/2006/relationships" id="264" r:id="Rbb3422b700fe43d2"/>
+    <p:sldId xmlns:r="http://schemas.openxmlformats.org/officeDocument/2006/relationships" id="265" r:id="Rc305d91ebc0d4bba"/>
   </p:sldIdLst>
   <p:sldSz cx="12192000" cy="6858000"/>
   <p:notesSz cx="6858000" cy="9144000"/>
@@ -1424,7 +1424,7 @@
   </p:cSld>
   <p:clrMap bg1="lt1" tx1="dk1" bg2="lt2" tx2="dk2" accent1="accent1" accent2="accent2" accent3="accent3" accent4="accent4" accent5="accent5" accent6="accent6" hlink="hlink" folHlink="folHlink"/>
   <p:sldLayoutIdLst>
-    <p:sldLayoutId xmlns:r="http://schemas.openxmlformats.org/officeDocument/2006/relationships" id="2147483649" r:id="Refcee42bc996487f"/>
+    <p:sldLayoutId xmlns:r="http://schemas.openxmlformats.org/officeDocument/2006/relationships" id="2147483649" r:id="R0ba959bda8a74862"/>
   </p:sldLayoutIdLst>
   <p:txStyles>
     <p:titleStyle>
@@ -2005,6 +2005,7 @@
           <a:lstStyle xmlns:a="http://schemas.openxmlformats.org/drawingml/2006/main"/>
           <a:p xmlns:a="http://schemas.openxmlformats.org/drawingml/2006/main">
             <a:pPr algn="l">
+              <a:buNone/>
               <a:defRPr sz="1125" b="1">
                 <a:solidFill>
                   <a:srgbClr val="5F6670"/>
@@ -2063,6 +2064,7 @@
           <a:lstStyle xmlns:a="http://schemas.openxmlformats.org/drawingml/2006/main"/>
           <a:p xmlns:a="http://schemas.openxmlformats.org/drawingml/2006/main">
             <a:pPr algn="l">
+              <a:buNone/>
               <a:defRPr sz="5400" b="1">
                 <a:solidFill>
                   <a:srgbClr val="111111"/>
@@ -2086,6 +2088,7 @@
           </a:p>
           <a:p xmlns:a="http://schemas.openxmlformats.org/drawingml/2006/main">
             <a:pPr algn="l">
+              <a:buNone/>
               <a:defRPr sz="5400" b="1">
                 <a:solidFill>
                   <a:srgbClr val="111111"/>
@@ -2175,6 +2178,7 @@
           <a:lstStyle xmlns:a="http://schemas.openxmlformats.org/drawingml/2006/main"/>
           <a:p xmlns:a="http://schemas.openxmlformats.org/drawingml/2006/main">
             <a:pPr algn="l">
+              <a:buNone/>
               <a:defRPr sz="2250" b="0">
                 <a:solidFill>
                   <a:srgbClr val="5F6670"/>
@@ -2233,6 +2237,7 @@
           <a:lstStyle xmlns:a="http://schemas.openxmlformats.org/drawingml/2006/main"/>
           <a:p xmlns:a="http://schemas.openxmlformats.org/drawingml/2006/main">
             <a:pPr algn="l">
+              <a:buNone/>
               <a:defRPr sz="1500" b="1">
                 <a:solidFill>
                   <a:srgbClr val="111111"/>
@@ -2291,6 +2296,7 @@
           <a:lstStyle xmlns:a="http://schemas.openxmlformats.org/drawingml/2006/main"/>
           <a:p xmlns:a="http://schemas.openxmlformats.org/drawingml/2006/main">
             <a:pPr algn="l">
+              <a:buNone/>
               <a:defRPr sz="1275" b="0">
                 <a:solidFill>
                   <a:srgbClr val="5F6670"/>
@@ -2349,6 +2355,7 @@
           <a:lstStyle xmlns:a="http://schemas.openxmlformats.org/drawingml/2006/main"/>
           <a:p xmlns:a="http://schemas.openxmlformats.org/drawingml/2006/main">
             <a:pPr algn="r">
+              <a:buNone/>
               <a:defRPr sz="1125" b="0">
                 <a:solidFill>
                   <a:srgbClr val="5F6670"/>
@@ -2436,6 +2443,7 @@
           <a:lstStyle xmlns:a="http://schemas.openxmlformats.org/drawingml/2006/main"/>
           <a:p xmlns:a="http://schemas.openxmlformats.org/drawingml/2006/main">
             <a:pPr algn="l">
+              <a:buNone/>
               <a:defRPr sz="1125" b="1">
                 <a:solidFill>
                   <a:srgbClr val="5F6670"/>
@@ -2494,6 +2502,7 @@
           <a:lstStyle xmlns:a="http://schemas.openxmlformats.org/drawingml/2006/main"/>
           <a:p xmlns:a="http://schemas.openxmlformats.org/drawingml/2006/main">
             <a:pPr algn="l">
+              <a:buNone/>
               <a:defRPr sz="3525" b="1">
                 <a:solidFill>
                   <a:srgbClr val="111111"/>
@@ -2552,6 +2561,7 @@
           <a:lstStyle xmlns:a="http://schemas.openxmlformats.org/drawingml/2006/main"/>
           <a:p xmlns:a="http://schemas.openxmlformats.org/drawingml/2006/main">
             <a:pPr algn="r">
+              <a:buNone/>
               <a:defRPr sz="1125" b="0">
                 <a:solidFill>
                   <a:srgbClr val="5F6670"/>
@@ -2765,6 +2775,7 @@
           <a:lstStyle xmlns:a="http://schemas.openxmlformats.org/drawingml/2006/main"/>
           <a:p xmlns:a="http://schemas.openxmlformats.org/drawingml/2006/main">
             <a:pPr algn="l">
+              <a:buNone/>
               <a:defRPr sz="1200" b="1">
                 <a:solidFill>
                   <a:srgbClr val="3D8DFF"/>
@@ -2823,6 +2834,7 @@
           <a:lstStyle xmlns:a="http://schemas.openxmlformats.org/drawingml/2006/main"/>
           <a:p xmlns:a="http://schemas.openxmlformats.org/drawingml/2006/main">
             <a:pPr algn="l">
+              <a:buNone/>
               <a:defRPr sz="2100" b="1">
                 <a:solidFill>
                   <a:srgbClr val="111111"/>
@@ -2881,6 +2893,7 @@
           <a:lstStyle xmlns:a="http://schemas.openxmlformats.org/drawingml/2006/main"/>
           <a:p xmlns:a="http://schemas.openxmlformats.org/drawingml/2006/main">
             <a:pPr algn="l">
+              <a:buNone/>
               <a:defRPr sz="1575" b="0">
                 <a:solidFill>
                   <a:srgbClr val="5F6670"/>
@@ -2970,6 +2983,7 @@
           <a:lstStyle xmlns:a="http://schemas.openxmlformats.org/drawingml/2006/main"/>
           <a:p xmlns:a="http://schemas.openxmlformats.org/drawingml/2006/main">
             <a:pPr algn="l">
+              <a:buNone/>
               <a:defRPr sz="1200" b="1">
                 <a:solidFill>
                   <a:srgbClr val="5F6670"/>
@@ -3028,6 +3042,7 @@
           <a:lstStyle xmlns:a="http://schemas.openxmlformats.org/drawingml/2006/main"/>
           <a:p xmlns:a="http://schemas.openxmlformats.org/drawingml/2006/main">
             <a:pPr algn="l">
+              <a:buNone/>
               <a:defRPr sz="2100" b="1">
                 <a:solidFill>
                   <a:srgbClr val="111111"/>
@@ -3086,6 +3101,7 @@
           <a:lstStyle xmlns:a="http://schemas.openxmlformats.org/drawingml/2006/main"/>
           <a:p xmlns:a="http://schemas.openxmlformats.org/drawingml/2006/main">
             <a:pPr algn="l">
+              <a:buNone/>
               <a:defRPr sz="1575" b="0">
                 <a:solidFill>
                   <a:srgbClr val="5F6670"/>
@@ -3175,6 +3191,7 @@
           <a:lstStyle xmlns:a="http://schemas.openxmlformats.org/drawingml/2006/main"/>
           <a:p xmlns:a="http://schemas.openxmlformats.org/drawingml/2006/main">
             <a:pPr algn="l">
+              <a:buNone/>
               <a:defRPr sz="1200" b="1">
                 <a:solidFill>
                   <a:srgbClr val="5F6670"/>
@@ -3233,6 +3250,7 @@
           <a:lstStyle xmlns:a="http://schemas.openxmlformats.org/drawingml/2006/main"/>
           <a:p xmlns:a="http://schemas.openxmlformats.org/drawingml/2006/main">
             <a:pPr algn="l">
+              <a:buNone/>
               <a:defRPr sz="2100" b="1">
                 <a:solidFill>
                   <a:srgbClr val="111111"/>
@@ -3291,6 +3309,7 @@
           <a:lstStyle xmlns:a="http://schemas.openxmlformats.org/drawingml/2006/main"/>
           <a:p xmlns:a="http://schemas.openxmlformats.org/drawingml/2006/main">
             <a:pPr algn="l">
+              <a:buNone/>
               <a:defRPr sz="1575" b="0">
                 <a:solidFill>
                   <a:srgbClr val="5F6670"/>
@@ -3349,6 +3368,7 @@
           <a:lstStyle xmlns:a="http://schemas.openxmlformats.org/drawingml/2006/main"/>
           <a:p xmlns:a="http://schemas.openxmlformats.org/drawingml/2006/main">
             <a:pPr algn="l">
+              <a:buNone/>
               <a:defRPr sz="1500" b="1">
                 <a:solidFill>
                   <a:srgbClr val="3D8DFF"/>
@@ -3407,6 +3427,7 @@
           <a:lstStyle xmlns:a="http://schemas.openxmlformats.org/drawingml/2006/main"/>
           <a:p xmlns:a="http://schemas.openxmlformats.org/drawingml/2006/main">
             <a:pPr algn="l">
+              <a:buNone/>
               <a:defRPr sz="2175" b="1">
                 <a:solidFill>
                   <a:srgbClr val="111111"/>
@@ -3494,6 +3515,7 @@
           <a:lstStyle xmlns:a="http://schemas.openxmlformats.org/drawingml/2006/main"/>
           <a:p xmlns:a="http://schemas.openxmlformats.org/drawingml/2006/main">
             <a:pPr algn="l">
+              <a:buNone/>
               <a:defRPr sz="1125" b="1">
                 <a:solidFill>
                   <a:srgbClr val="5F6670"/>
@@ -3552,6 +3574,7 @@
           <a:lstStyle xmlns:a="http://schemas.openxmlformats.org/drawingml/2006/main"/>
           <a:p xmlns:a="http://schemas.openxmlformats.org/drawingml/2006/main">
             <a:pPr algn="l">
+              <a:buNone/>
               <a:defRPr sz="3525" b="1">
                 <a:solidFill>
                   <a:srgbClr val="111111"/>
@@ -3610,6 +3633,7 @@
           <a:lstStyle xmlns:a="http://schemas.openxmlformats.org/drawingml/2006/main"/>
           <a:p xmlns:a="http://schemas.openxmlformats.org/drawingml/2006/main">
             <a:pPr algn="r">
+              <a:buNone/>
               <a:defRPr sz="1125" b="0">
                 <a:solidFill>
                   <a:srgbClr val="5F6670"/>
@@ -3763,6 +3787,7 @@
           <a:lstStyle xmlns:a="http://schemas.openxmlformats.org/drawingml/2006/main"/>
           <a:p xmlns:a="http://schemas.openxmlformats.org/drawingml/2006/main">
             <a:pPr algn="l">
+              <a:buNone/>
               <a:defRPr sz="1200" b="1">
                 <a:solidFill>
                   <a:srgbClr val="5F6670"/>
@@ -3816,11 +3841,12 @@
         </p:spPr>
         <p:txBody>
           <a:bodyPr xmlns:a="http://schemas.openxmlformats.org/drawingml/2006/main" anchor="t">
-            <a:normAutofit fontScale="92866"/>
+            <a:normAutofit fontScale="92863"/>
           </a:bodyPr>
           <a:lstStyle xmlns:a="http://schemas.openxmlformats.org/drawingml/2006/main"/>
           <a:p xmlns:a="http://schemas.openxmlformats.org/drawingml/2006/main">
             <a:pPr algn="l">
+              <a:buNone/>
               <a:defRPr sz="2325" b="1">
                 <a:solidFill>
                   <a:srgbClr val="111111"/>
@@ -3839,7 +3865,29 @@
                 <a:ea typeface="Arial"/>
                 <a:cs typeface="Arial"/>
               </a:rPr>
-              <a:t>The project team repeatedly opens links and re-checks dates.</a:t>
+              <a:t>The </a:t>
+            </a:r>
+            <a:r>
+              <a:rPr sz="2325" b="1">
+                <a:solidFill>
+                  <a:srgbClr val="111111"/>
+                </a:solidFill>
+                <a:latin typeface="Arial"/>
+                <a:ea typeface="Arial"/>
+                <a:cs typeface="Arial"/>
+              </a:rPr>
+              <a:t>operations team</a:t>
+            </a:r>
+            <a:r>
+              <a:rPr sz="2325" b="1">
+                <a:solidFill>
+                  <a:srgbClr val="111111"/>
+                </a:solidFill>
+                <a:latin typeface="Arial"/>
+                <a:ea typeface="Arial"/>
+                <a:cs typeface="Arial"/>
+              </a:rPr>
+              <a:t> repeatedly opens links and re-checks dates.</a:t>
             </a:r>
           </a:p>
         </p:txBody>
@@ -3910,6 +3958,7 @@
           <a:lstStyle xmlns:a="http://schemas.openxmlformats.org/drawingml/2006/main"/>
           <a:p xmlns:a="http://schemas.openxmlformats.org/drawingml/2006/main">
             <a:pPr algn="l">
+              <a:buNone/>
               <a:defRPr sz="1575" b="0">
                 <a:solidFill>
                   <a:srgbClr val="111111"/>
@@ -3999,6 +4048,7 @@
           <a:lstStyle xmlns:a="http://schemas.openxmlformats.org/drawingml/2006/main"/>
           <a:p xmlns:a="http://schemas.openxmlformats.org/drawingml/2006/main">
             <a:pPr algn="l">
+              <a:buNone/>
               <a:defRPr sz="1575" b="0">
                 <a:solidFill>
                   <a:srgbClr val="111111"/>
@@ -4088,6 +4138,7 @@
           <a:lstStyle xmlns:a="http://schemas.openxmlformats.org/drawingml/2006/main"/>
           <a:p xmlns:a="http://schemas.openxmlformats.org/drawingml/2006/main">
             <a:pPr algn="l">
+              <a:buNone/>
               <a:defRPr sz="1575" b="0">
                 <a:solidFill>
                   <a:srgbClr val="111111"/>
@@ -4146,6 +4197,7 @@
           <a:lstStyle xmlns:a="http://schemas.openxmlformats.org/drawingml/2006/main"/>
           <a:p xmlns:a="http://schemas.openxmlformats.org/drawingml/2006/main">
             <a:pPr algn="l">
+              <a:buNone/>
               <a:defRPr sz="1200" b="1">
                 <a:solidFill>
                   <a:srgbClr val="5F6670"/>
@@ -4204,6 +4256,7 @@
           <a:lstStyle xmlns:a="http://schemas.openxmlformats.org/drawingml/2006/main"/>
           <a:p xmlns:a="http://schemas.openxmlformats.org/drawingml/2006/main">
             <a:pPr algn="l">
+              <a:buNone/>
               <a:defRPr sz="2325" b="1">
                 <a:solidFill>
                   <a:srgbClr val="111111"/>
@@ -4293,6 +4346,7 @@
           <a:lstStyle xmlns:a="http://schemas.openxmlformats.org/drawingml/2006/main"/>
           <a:p xmlns:a="http://schemas.openxmlformats.org/drawingml/2006/main">
             <a:pPr algn="l">
+              <a:buNone/>
               <a:defRPr sz="1575" b="0">
                 <a:solidFill>
                   <a:srgbClr val="111111"/>
@@ -4382,6 +4436,7 @@
           <a:lstStyle xmlns:a="http://schemas.openxmlformats.org/drawingml/2006/main"/>
           <a:p xmlns:a="http://schemas.openxmlformats.org/drawingml/2006/main">
             <a:pPr algn="l">
+              <a:buNone/>
               <a:defRPr sz="1575" b="0">
                 <a:solidFill>
                   <a:srgbClr val="111111"/>
@@ -4471,6 +4526,7 @@
           <a:lstStyle xmlns:a="http://schemas.openxmlformats.org/drawingml/2006/main"/>
           <a:p xmlns:a="http://schemas.openxmlformats.org/drawingml/2006/main">
             <a:pPr algn="l">
+              <a:buNone/>
               <a:defRPr sz="1575" b="0">
                 <a:solidFill>
                   <a:srgbClr val="111111"/>
@@ -4558,6 +4614,7 @@
           <a:lstStyle xmlns:a="http://schemas.openxmlformats.org/drawingml/2006/main"/>
           <a:p xmlns:a="http://schemas.openxmlformats.org/drawingml/2006/main">
             <a:pPr algn="l">
+              <a:buNone/>
               <a:defRPr sz="1125" b="1">
                 <a:solidFill>
                   <a:srgbClr val="5F6670"/>
@@ -4616,6 +4673,7 @@
           <a:lstStyle xmlns:a="http://schemas.openxmlformats.org/drawingml/2006/main"/>
           <a:p xmlns:a="http://schemas.openxmlformats.org/drawingml/2006/main">
             <a:pPr algn="l">
+              <a:buNone/>
               <a:defRPr sz="3525" b="1">
                 <a:solidFill>
                   <a:srgbClr val="111111"/>
@@ -4674,6 +4732,7 @@
           <a:lstStyle xmlns:a="http://schemas.openxmlformats.org/drawingml/2006/main"/>
           <a:p xmlns:a="http://schemas.openxmlformats.org/drawingml/2006/main">
             <a:pPr algn="r">
+              <a:buNone/>
               <a:defRPr sz="1125" b="0">
                 <a:solidFill>
                   <a:srgbClr val="5F6670"/>
@@ -4794,6 +4853,7 @@
           <a:lstStyle xmlns:a="http://schemas.openxmlformats.org/drawingml/2006/main"/>
           <a:p xmlns:a="http://schemas.openxmlformats.org/drawingml/2006/main">
             <a:pPr algn="l">
+              <a:buNone/>
               <a:defRPr sz="4500" b="1">
                 <a:solidFill>
                   <a:srgbClr val="3D8DFF"/>
@@ -4852,6 +4912,7 @@
           <a:lstStyle xmlns:a="http://schemas.openxmlformats.org/drawingml/2006/main"/>
           <a:p xmlns:a="http://schemas.openxmlformats.org/drawingml/2006/main">
             <a:pPr algn="l">
+              <a:buNone/>
               <a:defRPr sz="2400" b="1">
                 <a:solidFill>
                   <a:srgbClr val="111111"/>
@@ -4910,6 +4971,7 @@
           <a:lstStyle xmlns:a="http://schemas.openxmlformats.org/drawingml/2006/main"/>
           <a:p xmlns:a="http://schemas.openxmlformats.org/drawingml/2006/main">
             <a:pPr algn="l">
+              <a:buNone/>
               <a:defRPr sz="1725" b="0">
                 <a:solidFill>
                   <a:srgbClr val="5F6670"/>
@@ -4999,6 +5061,7 @@
           <a:lstStyle xmlns:a="http://schemas.openxmlformats.org/drawingml/2006/main"/>
           <a:p xmlns:a="http://schemas.openxmlformats.org/drawingml/2006/main">
             <a:pPr algn="l">
+              <a:buNone/>
               <a:defRPr sz="4500" b="1">
                 <a:solidFill>
                   <a:srgbClr val="3D8DFF"/>
@@ -5057,6 +5120,7 @@
           <a:lstStyle xmlns:a="http://schemas.openxmlformats.org/drawingml/2006/main"/>
           <a:p xmlns:a="http://schemas.openxmlformats.org/drawingml/2006/main">
             <a:pPr algn="l">
+              <a:buNone/>
               <a:defRPr sz="2400" b="1">
                 <a:solidFill>
                   <a:srgbClr val="111111"/>
@@ -5115,6 +5179,7 @@
           <a:lstStyle xmlns:a="http://schemas.openxmlformats.org/drawingml/2006/main"/>
           <a:p xmlns:a="http://schemas.openxmlformats.org/drawingml/2006/main">
             <a:pPr algn="l">
+              <a:buNone/>
               <a:defRPr sz="1725" b="0">
                 <a:solidFill>
                   <a:srgbClr val="5F6670"/>
@@ -5204,6 +5269,7 @@
           <a:lstStyle xmlns:a="http://schemas.openxmlformats.org/drawingml/2006/main"/>
           <a:p xmlns:a="http://schemas.openxmlformats.org/drawingml/2006/main">
             <a:pPr algn="l">
+              <a:buNone/>
               <a:defRPr sz="4500" b="1">
                 <a:solidFill>
                   <a:srgbClr val="3D8DFF"/>
@@ -5262,6 +5328,7 @@
           <a:lstStyle xmlns:a="http://schemas.openxmlformats.org/drawingml/2006/main"/>
           <a:p xmlns:a="http://schemas.openxmlformats.org/drawingml/2006/main">
             <a:pPr algn="l">
+              <a:buNone/>
               <a:defRPr sz="2400" b="1">
                 <a:solidFill>
                   <a:srgbClr val="111111"/>
@@ -5320,6 +5387,7 @@
           <a:lstStyle xmlns:a="http://schemas.openxmlformats.org/drawingml/2006/main"/>
           <a:p xmlns:a="http://schemas.openxmlformats.org/drawingml/2006/main">
             <a:pPr algn="l">
+              <a:buNone/>
               <a:defRPr sz="1725" b="0">
                 <a:solidFill>
                   <a:srgbClr val="5F6670"/>
@@ -5409,6 +5477,7 @@
           <a:lstStyle xmlns:a="http://schemas.openxmlformats.org/drawingml/2006/main"/>
           <a:p xmlns:a="http://schemas.openxmlformats.org/drawingml/2006/main">
             <a:pPr algn="l">
+              <a:buNone/>
               <a:defRPr sz="1875" b="1">
                 <a:solidFill>
                   <a:srgbClr val="111111"/>
@@ -5496,6 +5565,7 @@
           <a:lstStyle xmlns:a="http://schemas.openxmlformats.org/drawingml/2006/main"/>
           <a:p xmlns:a="http://schemas.openxmlformats.org/drawingml/2006/main">
             <a:pPr algn="l">
+              <a:buNone/>
               <a:defRPr sz="1125" b="1">
                 <a:solidFill>
                   <a:srgbClr val="5F6670"/>
@@ -5554,6 +5624,7 @@
           <a:lstStyle xmlns:a="http://schemas.openxmlformats.org/drawingml/2006/main"/>
           <a:p xmlns:a="http://schemas.openxmlformats.org/drawingml/2006/main">
             <a:pPr algn="l">
+              <a:buNone/>
               <a:defRPr sz="3525" b="1">
                 <a:solidFill>
                   <a:srgbClr val="111111"/>
@@ -5612,6 +5683,7 @@
           <a:lstStyle xmlns:a="http://schemas.openxmlformats.org/drawingml/2006/main"/>
           <a:p xmlns:a="http://schemas.openxmlformats.org/drawingml/2006/main">
             <a:pPr algn="r">
+              <a:buNone/>
               <a:defRPr sz="1125" b="0">
                 <a:solidFill>
                   <a:srgbClr val="5F6670"/>
@@ -5670,6 +5742,7 @@
           <a:lstStyle xmlns:a="http://schemas.openxmlformats.org/drawingml/2006/main"/>
           <a:p xmlns:a="http://schemas.openxmlformats.org/drawingml/2006/main">
             <a:pPr algn="l">
+              <a:buNone/>
               <a:defRPr sz="3600" b="1">
                 <a:solidFill>
                   <a:srgbClr val="3D8DFF"/>
@@ -5728,6 +5801,7 @@
           <a:lstStyle xmlns:a="http://schemas.openxmlformats.org/drawingml/2006/main"/>
           <a:p xmlns:a="http://schemas.openxmlformats.org/drawingml/2006/main">
             <a:pPr algn="l">
+              <a:buNone/>
               <a:defRPr sz="2100" b="1">
                 <a:solidFill>
                   <a:srgbClr val="111111"/>
@@ -5786,6 +5860,7 @@
           <a:lstStyle xmlns:a="http://schemas.openxmlformats.org/drawingml/2006/main"/>
           <a:p xmlns:a="http://schemas.openxmlformats.org/drawingml/2006/main">
             <a:pPr algn="l">
+              <a:buNone/>
               <a:defRPr sz="1575" b="0">
                 <a:solidFill>
                   <a:srgbClr val="5F6670"/>
@@ -5875,6 +5950,7 @@
           <a:lstStyle xmlns:a="http://schemas.openxmlformats.org/drawingml/2006/main"/>
           <a:p xmlns:a="http://schemas.openxmlformats.org/drawingml/2006/main">
             <a:pPr algn="l">
+              <a:buNone/>
               <a:defRPr sz="1350" b="1">
                 <a:solidFill>
                   <a:srgbClr val="111111"/>
@@ -5933,6 +6009,7 @@
           <a:lstStyle xmlns:a="http://schemas.openxmlformats.org/drawingml/2006/main"/>
           <a:p xmlns:a="http://schemas.openxmlformats.org/drawingml/2006/main">
             <a:pPr algn="l">
+              <a:buNone/>
               <a:defRPr sz="3600" b="1">
                 <a:solidFill>
                   <a:srgbClr val="F57C00"/>
@@ -5991,6 +6068,7 @@
           <a:lstStyle xmlns:a="http://schemas.openxmlformats.org/drawingml/2006/main"/>
           <a:p xmlns:a="http://schemas.openxmlformats.org/drawingml/2006/main">
             <a:pPr algn="l">
+              <a:buNone/>
               <a:defRPr sz="2100" b="1">
                 <a:solidFill>
                   <a:srgbClr val="111111"/>
@@ -6049,6 +6127,7 @@
           <a:lstStyle xmlns:a="http://schemas.openxmlformats.org/drawingml/2006/main"/>
           <a:p xmlns:a="http://schemas.openxmlformats.org/drawingml/2006/main">
             <a:pPr algn="l">
+              <a:buNone/>
               <a:defRPr sz="1575" b="0">
                 <a:solidFill>
                   <a:srgbClr val="5F6670"/>
@@ -6138,6 +6217,7 @@
           <a:lstStyle xmlns:a="http://schemas.openxmlformats.org/drawingml/2006/main"/>
           <a:p xmlns:a="http://schemas.openxmlformats.org/drawingml/2006/main">
             <a:pPr algn="l">
+              <a:buNone/>
               <a:defRPr sz="1350" b="1">
                 <a:solidFill>
                   <a:srgbClr val="111111"/>
@@ -6196,6 +6276,7 @@
           <a:lstStyle xmlns:a="http://schemas.openxmlformats.org/drawingml/2006/main"/>
           <a:p xmlns:a="http://schemas.openxmlformats.org/drawingml/2006/main">
             <a:pPr algn="l">
+              <a:buNone/>
               <a:defRPr sz="3600" b="1">
                 <a:solidFill>
                   <a:srgbClr val="3D8DFF"/>
@@ -6254,6 +6335,7 @@
           <a:lstStyle xmlns:a="http://schemas.openxmlformats.org/drawingml/2006/main"/>
           <a:p xmlns:a="http://schemas.openxmlformats.org/drawingml/2006/main">
             <a:pPr algn="l">
+              <a:buNone/>
               <a:defRPr sz="2100" b="1">
                 <a:solidFill>
                   <a:srgbClr val="111111"/>
@@ -6312,6 +6394,7 @@
           <a:lstStyle xmlns:a="http://schemas.openxmlformats.org/drawingml/2006/main"/>
           <a:p xmlns:a="http://schemas.openxmlformats.org/drawingml/2006/main">
             <a:pPr algn="l">
+              <a:buNone/>
               <a:defRPr sz="1575" b="0">
                 <a:solidFill>
                   <a:srgbClr val="5F6670"/>
@@ -6401,6 +6484,7 @@
           <a:lstStyle xmlns:a="http://schemas.openxmlformats.org/drawingml/2006/main"/>
           <a:p xmlns:a="http://schemas.openxmlformats.org/drawingml/2006/main">
             <a:pPr algn="l">
+              <a:buNone/>
               <a:defRPr sz="1350" b="1">
                 <a:solidFill>
                   <a:srgbClr val="111111"/>
@@ -6459,6 +6543,7 @@
           <a:lstStyle xmlns:a="http://schemas.openxmlformats.org/drawingml/2006/main"/>
           <a:p xmlns:a="http://schemas.openxmlformats.org/drawingml/2006/main">
             <a:pPr algn="l">
+              <a:buNone/>
               <a:defRPr sz="1875" b="1">
                 <a:solidFill>
                   <a:srgbClr val="111111"/>
@@ -6546,6 +6631,7 @@
           <a:lstStyle xmlns:a="http://schemas.openxmlformats.org/drawingml/2006/main"/>
           <a:p xmlns:a="http://schemas.openxmlformats.org/drawingml/2006/main">
             <a:pPr algn="l">
+              <a:buNone/>
               <a:defRPr sz="1125" b="1">
                 <a:solidFill>
                   <a:srgbClr val="5F6670"/>
@@ -6604,6 +6690,7 @@
           <a:lstStyle xmlns:a="http://schemas.openxmlformats.org/drawingml/2006/main"/>
           <a:p xmlns:a="http://schemas.openxmlformats.org/drawingml/2006/main">
             <a:pPr algn="l">
+              <a:buNone/>
               <a:defRPr sz="3525" b="1">
                 <a:solidFill>
                   <a:srgbClr val="111111"/>
@@ -6662,6 +6749,7 @@
           <a:lstStyle xmlns:a="http://schemas.openxmlformats.org/drawingml/2006/main"/>
           <a:p xmlns:a="http://schemas.openxmlformats.org/drawingml/2006/main">
             <a:pPr algn="r">
+              <a:buNone/>
               <a:defRPr sz="1125" b="0">
                 <a:solidFill>
                   <a:srgbClr val="5F6670"/>
@@ -6813,6 +6901,7 @@
           <a:lstStyle xmlns:a="http://schemas.openxmlformats.org/drawingml/2006/main"/>
           <a:p xmlns:a="http://schemas.openxmlformats.org/drawingml/2006/main">
             <a:pPr algn="l">
+              <a:buNone/>
               <a:defRPr sz="1200" b="1">
                 <a:solidFill>
                   <a:srgbClr val="5F6670"/>
@@ -6871,6 +6960,7 @@
           <a:lstStyle xmlns:a="http://schemas.openxmlformats.org/drawingml/2006/main"/>
           <a:p xmlns:a="http://schemas.openxmlformats.org/drawingml/2006/main">
             <a:pPr algn="l">
+              <a:buNone/>
               <a:defRPr sz="2100" b="1">
                 <a:solidFill>
                   <a:srgbClr val="111111"/>
@@ -6894,6 +6984,7 @@
           </a:p>
           <a:p xmlns:a="http://schemas.openxmlformats.org/drawingml/2006/main">
             <a:pPr algn="l">
+              <a:buNone/>
               <a:defRPr sz="2100" b="1">
                 <a:solidFill>
                   <a:srgbClr val="111111"/>
@@ -6983,6 +7074,7 @@
           <a:lstStyle xmlns:a="http://schemas.openxmlformats.org/drawingml/2006/main"/>
           <a:p xmlns:a="http://schemas.openxmlformats.org/drawingml/2006/main">
             <a:pPr algn="l">
+              <a:buNone/>
               <a:defRPr sz="1200" b="1">
                 <a:solidFill>
                   <a:srgbClr val="5F6670"/>
@@ -7041,6 +7133,7 @@
           <a:lstStyle xmlns:a="http://schemas.openxmlformats.org/drawingml/2006/main"/>
           <a:p xmlns:a="http://schemas.openxmlformats.org/drawingml/2006/main">
             <a:pPr algn="l">
+              <a:buNone/>
               <a:defRPr sz="2700" b="1">
                 <a:solidFill>
                   <a:srgbClr val="111111"/>
@@ -7099,6 +7192,7 @@
           <a:lstStyle xmlns:a="http://schemas.openxmlformats.org/drawingml/2006/main"/>
           <a:p xmlns:a="http://schemas.openxmlformats.org/drawingml/2006/main">
             <a:pPr algn="l">
+              <a:buNone/>
               <a:defRPr sz="1575" b="0">
                 <a:solidFill>
                   <a:srgbClr val="111111"/>
@@ -7122,6 +7216,7 @@
           </a:p>
           <a:p xmlns:a="http://schemas.openxmlformats.org/drawingml/2006/main">
             <a:pPr algn="l">
+              <a:buNone/>
               <a:defRPr sz="1575" b="0">
                 <a:solidFill>
                   <a:srgbClr val="111111"/>
@@ -7145,6 +7240,7 @@
           </a:p>
           <a:p xmlns:a="http://schemas.openxmlformats.org/drawingml/2006/main">
             <a:pPr algn="l">
+              <a:buNone/>
               <a:defRPr sz="1575" b="0">
                 <a:solidFill>
                   <a:srgbClr val="111111"/>
@@ -7168,6 +7264,7 @@
           </a:p>
           <a:p xmlns:a="http://schemas.openxmlformats.org/drawingml/2006/main">
             <a:pPr algn="l">
+              <a:buNone/>
               <a:defRPr sz="1575" b="0">
                 <a:solidFill>
                   <a:srgbClr val="111111"/>
@@ -7257,6 +7354,7 @@
           <a:lstStyle xmlns:a="http://schemas.openxmlformats.org/drawingml/2006/main"/>
           <a:p xmlns:a="http://schemas.openxmlformats.org/drawingml/2006/main">
             <a:pPr algn="l">
+              <a:buNone/>
               <a:defRPr sz="1200" b="1">
                 <a:solidFill>
                   <a:srgbClr val="5F6670"/>
@@ -7315,6 +7413,7 @@
           <a:lstStyle xmlns:a="http://schemas.openxmlformats.org/drawingml/2006/main"/>
           <a:p xmlns:a="http://schemas.openxmlformats.org/drawingml/2006/main">
             <a:pPr algn="l">
+              <a:buNone/>
               <a:defRPr sz="2025" b="1">
                 <a:solidFill>
                   <a:srgbClr val="111111"/>
@@ -7373,6 +7472,7 @@
           <a:lstStyle xmlns:a="http://schemas.openxmlformats.org/drawingml/2006/main"/>
           <a:p xmlns:a="http://schemas.openxmlformats.org/drawingml/2006/main">
             <a:pPr algn="l">
+              <a:buNone/>
               <a:defRPr sz="1875" b="1">
                 <a:solidFill>
                   <a:srgbClr val="111111"/>
@@ -7431,6 +7531,7 @@
           <a:lstStyle xmlns:a="http://schemas.openxmlformats.org/drawingml/2006/main"/>
           <a:p xmlns:a="http://schemas.openxmlformats.org/drawingml/2006/main">
             <a:pPr algn="l">
+              <a:buNone/>
               <a:defRPr sz="1575" b="0">
                 <a:solidFill>
                   <a:srgbClr val="5F6670"/>
@@ -7489,6 +7590,7 @@
           <a:lstStyle xmlns:a="http://schemas.openxmlformats.org/drawingml/2006/main"/>
           <a:p xmlns:a="http://schemas.openxmlformats.org/drawingml/2006/main">
             <a:pPr algn="l">
+              <a:buNone/>
               <a:defRPr sz="1800" b="1">
                 <a:solidFill>
                   <a:srgbClr val="111111"/>
@@ -7576,6 +7678,7 @@
           <a:lstStyle xmlns:a="http://schemas.openxmlformats.org/drawingml/2006/main"/>
           <a:p xmlns:a="http://schemas.openxmlformats.org/drawingml/2006/main">
             <a:pPr algn="l">
+              <a:buNone/>
               <a:defRPr sz="1125" b="1">
                 <a:solidFill>
                   <a:srgbClr val="5F6670"/>
@@ -7634,6 +7737,7 @@
           <a:lstStyle xmlns:a="http://schemas.openxmlformats.org/drawingml/2006/main"/>
           <a:p xmlns:a="http://schemas.openxmlformats.org/drawingml/2006/main">
             <a:pPr algn="l">
+              <a:buNone/>
               <a:defRPr sz="3525" b="1">
                 <a:solidFill>
                   <a:srgbClr val="111111"/>
@@ -7692,6 +7796,7 @@
           <a:lstStyle xmlns:a="http://schemas.openxmlformats.org/drawingml/2006/main"/>
           <a:p xmlns:a="http://schemas.openxmlformats.org/drawingml/2006/main">
             <a:pPr algn="r">
+              <a:buNone/>
               <a:defRPr sz="1125" b="0">
                 <a:solidFill>
                   <a:srgbClr val="5F6670"/>
@@ -7781,6 +7886,7 @@
           <a:lstStyle xmlns:a="http://schemas.openxmlformats.org/drawingml/2006/main"/>
           <a:p xmlns:a="http://schemas.openxmlformats.org/drawingml/2006/main">
             <a:pPr algn="l">
+              <a:buNone/>
               <a:defRPr sz="1275" b="1">
                 <a:solidFill>
                   <a:srgbClr val="FFFFFF"/>
@@ -7839,6 +7945,7 @@
           <a:lstStyle xmlns:a="http://schemas.openxmlformats.org/drawingml/2006/main"/>
           <a:p xmlns:a="http://schemas.openxmlformats.org/drawingml/2006/main">
             <a:pPr algn="l">
+              <a:buNone/>
               <a:defRPr sz="1275" b="1">
                 <a:solidFill>
                   <a:srgbClr val="FFFFFF"/>
@@ -7897,6 +8004,7 @@
           <a:lstStyle xmlns:a="http://schemas.openxmlformats.org/drawingml/2006/main"/>
           <a:p xmlns:a="http://schemas.openxmlformats.org/drawingml/2006/main">
             <a:pPr algn="l">
+              <a:buNone/>
               <a:defRPr sz="1275" b="1">
                 <a:solidFill>
                   <a:srgbClr val="FFFFFF"/>
@@ -8019,6 +8127,7 @@
           <a:lstStyle xmlns:a="http://schemas.openxmlformats.org/drawingml/2006/main"/>
           <a:p xmlns:a="http://schemas.openxmlformats.org/drawingml/2006/main">
             <a:pPr algn="ctr">
+              <a:buNone/>
               <a:defRPr sz="1200" b="1">
                 <a:solidFill>
                   <a:srgbClr val="FFFFFF"/>
@@ -8077,6 +8186,7 @@
           <a:lstStyle xmlns:a="http://schemas.openxmlformats.org/drawingml/2006/main"/>
           <a:p xmlns:a="http://schemas.openxmlformats.org/drawingml/2006/main">
             <a:pPr algn="l">
+              <a:buNone/>
               <a:defRPr sz="1500" b="0">
                 <a:solidFill>
                   <a:srgbClr val="111111"/>
@@ -8135,6 +8245,7 @@
           <a:lstStyle xmlns:a="http://schemas.openxmlformats.org/drawingml/2006/main"/>
           <a:p xmlns:a="http://schemas.openxmlformats.org/drawingml/2006/main">
             <a:pPr algn="l">
+              <a:buNone/>
               <a:defRPr sz="1500" b="1">
                 <a:solidFill>
                   <a:srgbClr val="111111"/>
@@ -8257,6 +8368,7 @@
           <a:lstStyle xmlns:a="http://schemas.openxmlformats.org/drawingml/2006/main"/>
           <a:p xmlns:a="http://schemas.openxmlformats.org/drawingml/2006/main">
             <a:pPr algn="ctr">
+              <a:buNone/>
               <a:defRPr sz="1200" b="1">
                 <a:solidFill>
                   <a:srgbClr val="FFFFFF"/>
@@ -8315,6 +8427,7 @@
           <a:lstStyle xmlns:a="http://schemas.openxmlformats.org/drawingml/2006/main"/>
           <a:p xmlns:a="http://schemas.openxmlformats.org/drawingml/2006/main">
             <a:pPr algn="l">
+              <a:buNone/>
               <a:defRPr sz="1500" b="0">
                 <a:solidFill>
                   <a:srgbClr val="111111"/>
@@ -8373,6 +8486,7 @@
           <a:lstStyle xmlns:a="http://schemas.openxmlformats.org/drawingml/2006/main"/>
           <a:p xmlns:a="http://schemas.openxmlformats.org/drawingml/2006/main">
             <a:pPr algn="l">
+              <a:buNone/>
               <a:defRPr sz="1500" b="1">
                 <a:solidFill>
                   <a:srgbClr val="111111"/>
@@ -8495,6 +8609,7 @@
           <a:lstStyle xmlns:a="http://schemas.openxmlformats.org/drawingml/2006/main"/>
           <a:p xmlns:a="http://schemas.openxmlformats.org/drawingml/2006/main">
             <a:pPr algn="ctr">
+              <a:buNone/>
               <a:defRPr sz="1200" b="1">
                 <a:solidFill>
                   <a:srgbClr val="FFFFFF"/>
@@ -8553,6 +8668,7 @@
           <a:lstStyle xmlns:a="http://schemas.openxmlformats.org/drawingml/2006/main"/>
           <a:p xmlns:a="http://schemas.openxmlformats.org/drawingml/2006/main">
             <a:pPr algn="l">
+              <a:buNone/>
               <a:defRPr sz="1500" b="0">
                 <a:solidFill>
                   <a:srgbClr val="111111"/>
@@ -8611,6 +8727,7 @@
           <a:lstStyle xmlns:a="http://schemas.openxmlformats.org/drawingml/2006/main"/>
           <a:p xmlns:a="http://schemas.openxmlformats.org/drawingml/2006/main">
             <a:pPr algn="l">
+              <a:buNone/>
               <a:defRPr sz="1500" b="1">
                 <a:solidFill>
                   <a:srgbClr val="111111"/>
@@ -8733,6 +8850,7 @@
           <a:lstStyle xmlns:a="http://schemas.openxmlformats.org/drawingml/2006/main"/>
           <a:p xmlns:a="http://schemas.openxmlformats.org/drawingml/2006/main">
             <a:pPr algn="ctr">
+              <a:buNone/>
               <a:defRPr sz="1200" b="1">
                 <a:solidFill>
                   <a:srgbClr val="FFFFFF"/>
@@ -8791,6 +8909,7 @@
           <a:lstStyle xmlns:a="http://schemas.openxmlformats.org/drawingml/2006/main"/>
           <a:p xmlns:a="http://schemas.openxmlformats.org/drawingml/2006/main">
             <a:pPr algn="l">
+              <a:buNone/>
               <a:defRPr sz="1500" b="0">
                 <a:solidFill>
                   <a:srgbClr val="111111"/>
@@ -8849,6 +8968,7 @@
           <a:lstStyle xmlns:a="http://schemas.openxmlformats.org/drawingml/2006/main"/>
           <a:p xmlns:a="http://schemas.openxmlformats.org/drawingml/2006/main">
             <a:pPr algn="l">
+              <a:buNone/>
               <a:defRPr sz="1500" b="1">
                 <a:solidFill>
                   <a:srgbClr val="111111"/>
@@ -8971,6 +9091,7 @@
           <a:lstStyle xmlns:a="http://schemas.openxmlformats.org/drawingml/2006/main"/>
           <a:p xmlns:a="http://schemas.openxmlformats.org/drawingml/2006/main">
             <a:pPr algn="ctr">
+              <a:buNone/>
               <a:defRPr sz="1200" b="1">
                 <a:solidFill>
                   <a:srgbClr val="FFFFFF"/>
@@ -9029,6 +9150,7 @@
           <a:lstStyle xmlns:a="http://schemas.openxmlformats.org/drawingml/2006/main"/>
           <a:p xmlns:a="http://schemas.openxmlformats.org/drawingml/2006/main">
             <a:pPr algn="l">
+              <a:buNone/>
               <a:defRPr sz="1500" b="0">
                 <a:solidFill>
                   <a:srgbClr val="111111"/>
@@ -9087,6 +9209,7 @@
           <a:lstStyle xmlns:a="http://schemas.openxmlformats.org/drawingml/2006/main"/>
           <a:p xmlns:a="http://schemas.openxmlformats.org/drawingml/2006/main">
             <a:pPr algn="l">
+              <a:buNone/>
               <a:defRPr sz="1500" b="1">
                 <a:solidFill>
                   <a:srgbClr val="111111"/>
@@ -9145,6 +9268,7 @@
           <a:lstStyle xmlns:a="http://schemas.openxmlformats.org/drawingml/2006/main"/>
           <a:p xmlns:a="http://schemas.openxmlformats.org/drawingml/2006/main">
             <a:pPr algn="l">
+              <a:buNone/>
               <a:defRPr sz="1575" b="1">
                 <a:solidFill>
                   <a:srgbClr val="111111"/>
@@ -9203,6 +9327,7 @@
           <a:lstStyle xmlns:a="http://schemas.openxmlformats.org/drawingml/2006/main"/>
           <a:p xmlns:a="http://schemas.openxmlformats.org/drawingml/2006/main">
             <a:pPr algn="r">
+              <a:buNone/>
               <a:defRPr sz="1425" b="0">
                 <a:solidFill>
                   <a:srgbClr val="5F6670"/>
@@ -9290,6 +9415,7 @@
           <a:lstStyle xmlns:a="http://schemas.openxmlformats.org/drawingml/2006/main"/>
           <a:p xmlns:a="http://schemas.openxmlformats.org/drawingml/2006/main">
             <a:pPr algn="l">
+              <a:buNone/>
               <a:defRPr sz="1125" b="1">
                 <a:solidFill>
                   <a:srgbClr val="5F6670"/>
@@ -9348,6 +9474,7 @@
           <a:lstStyle xmlns:a="http://schemas.openxmlformats.org/drawingml/2006/main"/>
           <a:p xmlns:a="http://schemas.openxmlformats.org/drawingml/2006/main">
             <a:pPr algn="l">
+              <a:buNone/>
               <a:defRPr sz="3525" b="1">
                 <a:solidFill>
                   <a:srgbClr val="111111"/>
@@ -9406,6 +9533,7 @@
           <a:lstStyle xmlns:a="http://schemas.openxmlformats.org/drawingml/2006/main"/>
           <a:p xmlns:a="http://schemas.openxmlformats.org/drawingml/2006/main">
             <a:pPr algn="r">
+              <a:buNone/>
               <a:defRPr sz="1125" b="0">
                 <a:solidFill>
                   <a:srgbClr val="5F6670"/>
@@ -9495,6 +9623,7 @@
           <a:lstStyle xmlns:a="http://schemas.openxmlformats.org/drawingml/2006/main"/>
           <a:p xmlns:a="http://schemas.openxmlformats.org/drawingml/2006/main">
             <a:pPr algn="l">
+              <a:buNone/>
               <a:defRPr sz="1200" b="1">
                 <a:solidFill>
                   <a:srgbClr val="2E7D32"/>
@@ -9553,6 +9682,7 @@
           <a:lstStyle xmlns:a="http://schemas.openxmlformats.org/drawingml/2006/main"/>
           <a:p xmlns:a="http://schemas.openxmlformats.org/drawingml/2006/main">
             <a:pPr algn="l">
+              <a:buNone/>
               <a:defRPr sz="2550" b="1">
                 <a:solidFill>
                   <a:srgbClr val="111111"/>
@@ -9642,6 +9772,7 @@
           <a:lstStyle xmlns:a="http://schemas.openxmlformats.org/drawingml/2006/main"/>
           <a:p xmlns:a="http://schemas.openxmlformats.org/drawingml/2006/main">
             <a:pPr algn="l">
+              <a:buNone/>
               <a:defRPr sz="1575" b="0">
                 <a:solidFill>
                   <a:srgbClr val="111111"/>
@@ -9731,6 +9862,7 @@
           <a:lstStyle xmlns:a="http://schemas.openxmlformats.org/drawingml/2006/main"/>
           <a:p xmlns:a="http://schemas.openxmlformats.org/drawingml/2006/main">
             <a:pPr algn="l">
+              <a:buNone/>
               <a:defRPr sz="1575" b="0">
                 <a:solidFill>
                   <a:srgbClr val="111111"/>
@@ -9820,6 +9952,7 @@
           <a:lstStyle xmlns:a="http://schemas.openxmlformats.org/drawingml/2006/main"/>
           <a:p xmlns:a="http://schemas.openxmlformats.org/drawingml/2006/main">
             <a:pPr algn="l">
+              <a:buNone/>
               <a:defRPr sz="1575" b="0">
                 <a:solidFill>
                   <a:srgbClr val="111111"/>
@@ -9909,6 +10042,7 @@
           <a:lstStyle xmlns:a="http://schemas.openxmlformats.org/drawingml/2006/main"/>
           <a:p xmlns:a="http://schemas.openxmlformats.org/drawingml/2006/main">
             <a:pPr algn="l">
+              <a:buNone/>
               <a:defRPr sz="1575" b="0">
                 <a:solidFill>
                   <a:srgbClr val="111111"/>
@@ -9967,6 +10101,7 @@
           <a:lstStyle xmlns:a="http://schemas.openxmlformats.org/drawingml/2006/main"/>
           <a:p xmlns:a="http://schemas.openxmlformats.org/drawingml/2006/main">
             <a:pPr algn="l">
+              <a:buNone/>
               <a:defRPr sz="1350" b="1">
                 <a:solidFill>
                   <a:srgbClr val="111111"/>
@@ -10056,6 +10191,7 @@
           <a:lstStyle xmlns:a="http://schemas.openxmlformats.org/drawingml/2006/main"/>
           <a:p xmlns:a="http://schemas.openxmlformats.org/drawingml/2006/main">
             <a:pPr algn="l">
+              <a:buNone/>
               <a:defRPr sz="1200" b="1">
                 <a:solidFill>
                   <a:srgbClr val="3D8DFF"/>
@@ -10114,6 +10250,7 @@
           <a:lstStyle xmlns:a="http://schemas.openxmlformats.org/drawingml/2006/main"/>
           <a:p xmlns:a="http://schemas.openxmlformats.org/drawingml/2006/main">
             <a:pPr algn="l">
+              <a:buNone/>
               <a:defRPr sz="2550" b="1">
                 <a:solidFill>
                   <a:srgbClr val="111111"/>
@@ -10203,6 +10340,7 @@
           <a:lstStyle xmlns:a="http://schemas.openxmlformats.org/drawingml/2006/main"/>
           <a:p xmlns:a="http://schemas.openxmlformats.org/drawingml/2006/main">
             <a:pPr algn="l">
+              <a:buNone/>
               <a:defRPr sz="1575" b="0">
                 <a:solidFill>
                   <a:srgbClr val="111111"/>
@@ -10292,6 +10430,7 @@
           <a:lstStyle xmlns:a="http://schemas.openxmlformats.org/drawingml/2006/main"/>
           <a:p xmlns:a="http://schemas.openxmlformats.org/drawingml/2006/main">
             <a:pPr algn="l">
+              <a:buNone/>
               <a:defRPr sz="1575" b="0">
                 <a:solidFill>
                   <a:srgbClr val="111111"/>
@@ -10381,6 +10520,7 @@
           <a:lstStyle xmlns:a="http://schemas.openxmlformats.org/drawingml/2006/main"/>
           <a:p xmlns:a="http://schemas.openxmlformats.org/drawingml/2006/main">
             <a:pPr algn="l">
+              <a:buNone/>
               <a:defRPr sz="1575" b="0">
                 <a:solidFill>
                   <a:srgbClr val="111111"/>
@@ -10470,6 +10610,7 @@
           <a:lstStyle xmlns:a="http://schemas.openxmlformats.org/drawingml/2006/main"/>
           <a:p xmlns:a="http://schemas.openxmlformats.org/drawingml/2006/main">
             <a:pPr algn="l">
+              <a:buNone/>
               <a:defRPr sz="1575" b="0">
                 <a:solidFill>
                   <a:srgbClr val="111111"/>
@@ -10528,6 +10669,7 @@
           <a:lstStyle xmlns:a="http://schemas.openxmlformats.org/drawingml/2006/main"/>
           <a:p xmlns:a="http://schemas.openxmlformats.org/drawingml/2006/main">
             <a:pPr algn="l">
+              <a:buNone/>
               <a:defRPr sz="1350" b="1">
                 <a:solidFill>
                   <a:srgbClr val="111111"/>
@@ -10586,6 +10728,7 @@
           <a:lstStyle xmlns:a="http://schemas.openxmlformats.org/drawingml/2006/main"/>
           <a:p xmlns:a="http://schemas.openxmlformats.org/drawingml/2006/main">
             <a:pPr algn="l">
+              <a:buNone/>
               <a:defRPr sz="1725" b="1">
                 <a:solidFill>
                   <a:srgbClr val="111111"/>
@@ -10673,6 +10816,7 @@
           <a:lstStyle xmlns:a="http://schemas.openxmlformats.org/drawingml/2006/main"/>
           <a:p xmlns:a="http://schemas.openxmlformats.org/drawingml/2006/main">
             <a:pPr algn="l">
+              <a:buNone/>
               <a:defRPr sz="1125" b="1">
                 <a:solidFill>
                   <a:srgbClr val="5F6670"/>
@@ -10731,6 +10875,7 @@
           <a:lstStyle xmlns:a="http://schemas.openxmlformats.org/drawingml/2006/main"/>
           <a:p xmlns:a="http://schemas.openxmlformats.org/drawingml/2006/main">
             <a:pPr algn="l">
+              <a:buNone/>
               <a:defRPr sz="3525" b="1">
                 <a:solidFill>
                   <a:srgbClr val="111111"/>
@@ -10789,6 +10934,7 @@
           <a:lstStyle xmlns:a="http://schemas.openxmlformats.org/drawingml/2006/main"/>
           <a:p xmlns:a="http://schemas.openxmlformats.org/drawingml/2006/main">
             <a:pPr algn="r">
+              <a:buNone/>
               <a:defRPr sz="1125" b="0">
                 <a:solidFill>
                   <a:srgbClr val="5F6670"/>
@@ -10909,6 +11055,7 @@
           <a:lstStyle xmlns:a="http://schemas.openxmlformats.org/drawingml/2006/main"/>
           <a:p xmlns:a="http://schemas.openxmlformats.org/drawingml/2006/main">
             <a:pPr algn="ctr">
+              <a:buNone/>
               <a:defRPr sz="2025" b="1">
                 <a:solidFill>
                   <a:srgbClr val="FFFFFF"/>
@@ -10967,6 +11114,7 @@
           <a:lstStyle xmlns:a="http://schemas.openxmlformats.org/drawingml/2006/main"/>
           <a:p xmlns:a="http://schemas.openxmlformats.org/drawingml/2006/main">
             <a:pPr algn="l">
+              <a:buNone/>
               <a:defRPr sz="1875" b="1">
                 <a:solidFill>
                   <a:srgbClr val="111111"/>
@@ -11025,6 +11173,7 @@
           <a:lstStyle xmlns:a="http://schemas.openxmlformats.org/drawingml/2006/main"/>
           <a:p xmlns:a="http://schemas.openxmlformats.org/drawingml/2006/main">
             <a:pPr algn="l">
+              <a:buNone/>
               <a:defRPr sz="1425" b="0">
                 <a:solidFill>
                   <a:srgbClr val="5F6670"/>
@@ -11145,6 +11294,7 @@
           <a:lstStyle xmlns:a="http://schemas.openxmlformats.org/drawingml/2006/main"/>
           <a:p xmlns:a="http://schemas.openxmlformats.org/drawingml/2006/main">
             <a:pPr algn="ctr">
+              <a:buNone/>
               <a:defRPr sz="2025" b="1">
                 <a:solidFill>
                   <a:srgbClr val="FFFFFF"/>
@@ -11203,6 +11353,7 @@
           <a:lstStyle xmlns:a="http://schemas.openxmlformats.org/drawingml/2006/main"/>
           <a:p xmlns:a="http://schemas.openxmlformats.org/drawingml/2006/main">
             <a:pPr algn="l">
+              <a:buNone/>
               <a:defRPr sz="1875" b="1">
                 <a:solidFill>
                   <a:srgbClr val="111111"/>
@@ -11261,6 +11412,7 @@
           <a:lstStyle xmlns:a="http://schemas.openxmlformats.org/drawingml/2006/main"/>
           <a:p xmlns:a="http://schemas.openxmlformats.org/drawingml/2006/main">
             <a:pPr algn="l">
+              <a:buNone/>
               <a:defRPr sz="1425" b="0">
                 <a:solidFill>
                   <a:srgbClr val="5F6670"/>
@@ -11381,6 +11533,7 @@
           <a:lstStyle xmlns:a="http://schemas.openxmlformats.org/drawingml/2006/main"/>
           <a:p xmlns:a="http://schemas.openxmlformats.org/drawingml/2006/main">
             <a:pPr algn="ctr">
+              <a:buNone/>
               <a:defRPr sz="2025" b="1">
                 <a:solidFill>
                   <a:srgbClr val="FFFFFF"/>
@@ -11439,6 +11592,7 @@
           <a:lstStyle xmlns:a="http://schemas.openxmlformats.org/drawingml/2006/main"/>
           <a:p xmlns:a="http://schemas.openxmlformats.org/drawingml/2006/main">
             <a:pPr algn="l">
+              <a:buNone/>
               <a:defRPr sz="1875" b="1">
                 <a:solidFill>
                   <a:srgbClr val="111111"/>
@@ -11497,6 +11651,7 @@
           <a:lstStyle xmlns:a="http://schemas.openxmlformats.org/drawingml/2006/main"/>
           <a:p xmlns:a="http://schemas.openxmlformats.org/drawingml/2006/main">
             <a:pPr algn="l">
+              <a:buNone/>
               <a:defRPr sz="1425" b="0">
                 <a:solidFill>
                   <a:srgbClr val="5F6670"/>
@@ -11617,6 +11772,7 @@
           <a:lstStyle xmlns:a="http://schemas.openxmlformats.org/drawingml/2006/main"/>
           <a:p xmlns:a="http://schemas.openxmlformats.org/drawingml/2006/main">
             <a:pPr algn="ctr">
+              <a:buNone/>
               <a:defRPr sz="2025" b="1">
                 <a:solidFill>
                   <a:srgbClr val="FFFFFF"/>
@@ -11675,6 +11831,7 @@
           <a:lstStyle xmlns:a="http://schemas.openxmlformats.org/drawingml/2006/main"/>
           <a:p xmlns:a="http://schemas.openxmlformats.org/drawingml/2006/main">
             <a:pPr algn="l">
+              <a:buNone/>
               <a:defRPr sz="1875" b="1">
                 <a:solidFill>
                   <a:srgbClr val="111111"/>
@@ -11733,6 +11890,7 @@
           <a:lstStyle xmlns:a="http://schemas.openxmlformats.org/drawingml/2006/main"/>
           <a:p xmlns:a="http://schemas.openxmlformats.org/drawingml/2006/main">
             <a:pPr algn="l">
+              <a:buNone/>
               <a:defRPr sz="1425" b="0">
                 <a:solidFill>
                   <a:srgbClr val="5F6670"/>
@@ -11822,6 +11980,7 @@
           <a:lstStyle xmlns:a="http://schemas.openxmlformats.org/drawingml/2006/main"/>
           <a:p xmlns:a="http://schemas.openxmlformats.org/drawingml/2006/main">
             <a:pPr algn="l">
+              <a:buNone/>
               <a:defRPr sz="1200" b="1">
                 <a:solidFill>
                   <a:srgbClr val="5F6670"/>
@@ -11911,6 +12070,7 @@
           <a:lstStyle xmlns:a="http://schemas.openxmlformats.org/drawingml/2006/main"/>
           <a:p xmlns:a="http://schemas.openxmlformats.org/drawingml/2006/main">
             <a:pPr algn="l">
+              <a:buNone/>
               <a:defRPr sz="1575" b="0">
                 <a:solidFill>
                   <a:srgbClr val="111111"/>
@@ -12000,6 +12160,7 @@
           <a:lstStyle xmlns:a="http://schemas.openxmlformats.org/drawingml/2006/main"/>
           <a:p xmlns:a="http://schemas.openxmlformats.org/drawingml/2006/main">
             <a:pPr algn="l">
+              <a:buNone/>
               <a:defRPr sz="1575" b="0">
                 <a:solidFill>
                   <a:srgbClr val="111111"/>
@@ -12089,6 +12250,7 @@
           <a:lstStyle xmlns:a="http://schemas.openxmlformats.org/drawingml/2006/main"/>
           <a:p xmlns:a="http://schemas.openxmlformats.org/drawingml/2006/main">
             <a:pPr algn="l">
+              <a:buNone/>
               <a:defRPr sz="1575" b="0">
                 <a:solidFill>
                   <a:srgbClr val="111111"/>
@@ -12178,6 +12340,7 @@
           <a:lstStyle xmlns:a="http://schemas.openxmlformats.org/drawingml/2006/main"/>
           <a:p xmlns:a="http://schemas.openxmlformats.org/drawingml/2006/main">
             <a:pPr algn="l">
+              <a:buNone/>
               <a:defRPr sz="1575" b="0">
                 <a:solidFill>
                   <a:srgbClr val="111111"/>
@@ -12236,6 +12399,7 @@
           <a:lstStyle xmlns:a="http://schemas.openxmlformats.org/drawingml/2006/main"/>
           <a:p xmlns:a="http://schemas.openxmlformats.org/drawingml/2006/main">
             <a:pPr algn="l">
+              <a:buNone/>
               <a:defRPr sz="1425" b="0">
                 <a:solidFill>
                   <a:srgbClr val="5F6670"/>
@@ -12323,6 +12487,7 @@
           <a:lstStyle xmlns:a="http://schemas.openxmlformats.org/drawingml/2006/main"/>
           <a:p xmlns:a="http://schemas.openxmlformats.org/drawingml/2006/main">
             <a:pPr algn="l">
+              <a:buNone/>
               <a:defRPr sz="1125" b="1">
                 <a:solidFill>
                   <a:srgbClr val="5F6670"/>
@@ -12381,6 +12546,7 @@
           <a:lstStyle xmlns:a="http://schemas.openxmlformats.org/drawingml/2006/main"/>
           <a:p xmlns:a="http://schemas.openxmlformats.org/drawingml/2006/main">
             <a:pPr algn="l">
+              <a:buNone/>
               <a:defRPr sz="3525" b="1">
                 <a:solidFill>
                   <a:srgbClr val="111111"/>
@@ -12439,6 +12605,7 @@
           <a:lstStyle xmlns:a="http://schemas.openxmlformats.org/drawingml/2006/main"/>
           <a:p xmlns:a="http://schemas.openxmlformats.org/drawingml/2006/main">
             <a:pPr algn="r">
+              <a:buNone/>
               <a:defRPr sz="1125" b="0">
                 <a:solidFill>
                   <a:srgbClr val="5F6670"/>
@@ -12497,6 +12664,7 @@
           <a:lstStyle xmlns:a="http://schemas.openxmlformats.org/drawingml/2006/main"/>
           <a:p xmlns:a="http://schemas.openxmlformats.org/drawingml/2006/main">
             <a:pPr algn="l">
+              <a:buNone/>
               <a:defRPr sz="1200" b="1">
                 <a:solidFill>
                   <a:srgbClr val="5F6670"/>
@@ -12555,6 +12723,7 @@
           <a:lstStyle xmlns:a="http://schemas.openxmlformats.org/drawingml/2006/main"/>
           <a:p xmlns:a="http://schemas.openxmlformats.org/drawingml/2006/main">
             <a:pPr algn="l">
+              <a:buNone/>
               <a:defRPr sz="2325" b="1">
                 <a:solidFill>
                   <a:srgbClr val="111111"/>
@@ -12644,6 +12813,7 @@
           <a:lstStyle xmlns:a="http://schemas.openxmlformats.org/drawingml/2006/main"/>
           <a:p xmlns:a="http://schemas.openxmlformats.org/drawingml/2006/main">
             <a:pPr algn="l">
+              <a:buNone/>
               <a:defRPr sz="1575" b="0">
                 <a:solidFill>
                   <a:srgbClr val="111111"/>
@@ -12733,6 +12903,7 @@
           <a:lstStyle xmlns:a="http://schemas.openxmlformats.org/drawingml/2006/main"/>
           <a:p xmlns:a="http://schemas.openxmlformats.org/drawingml/2006/main">
             <a:pPr algn="l">
+              <a:buNone/>
               <a:defRPr sz="1575" b="0">
                 <a:solidFill>
                   <a:srgbClr val="111111"/>
@@ -12822,6 +12993,7 @@
           <a:lstStyle xmlns:a="http://schemas.openxmlformats.org/drawingml/2006/main"/>
           <a:p xmlns:a="http://schemas.openxmlformats.org/drawingml/2006/main">
             <a:pPr algn="l">
+              <a:buNone/>
               <a:defRPr sz="1575" b="0">
                 <a:solidFill>
                   <a:srgbClr val="111111"/>
@@ -12911,6 +13083,7 @@
           <a:lstStyle xmlns:a="http://schemas.openxmlformats.org/drawingml/2006/main"/>
           <a:p xmlns:a="http://schemas.openxmlformats.org/drawingml/2006/main">
             <a:pPr algn="l">
+              <a:buNone/>
               <a:defRPr sz="1575" b="0">
                 <a:solidFill>
                   <a:srgbClr val="111111"/>
@@ -13000,6 +13173,7 @@
           <a:lstStyle xmlns:a="http://schemas.openxmlformats.org/drawingml/2006/main"/>
           <a:p xmlns:a="http://schemas.openxmlformats.org/drawingml/2006/main">
             <a:pPr algn="l">
+              <a:buNone/>
               <a:defRPr sz="1200" b="1">
                 <a:solidFill>
                   <a:srgbClr val="5F6670"/>
@@ -13058,6 +13232,7 @@
           <a:lstStyle xmlns:a="http://schemas.openxmlformats.org/drawingml/2006/main"/>
           <a:p xmlns:a="http://schemas.openxmlformats.org/drawingml/2006/main">
             <a:pPr algn="l">
+              <a:buNone/>
               <a:defRPr sz="2325" b="1">
                 <a:solidFill>
                   <a:srgbClr val="111111"/>
@@ -13147,6 +13322,7 @@
           <a:lstStyle xmlns:a="http://schemas.openxmlformats.org/drawingml/2006/main"/>
           <a:p xmlns:a="http://schemas.openxmlformats.org/drawingml/2006/main">
             <a:pPr algn="l">
+              <a:buNone/>
               <a:defRPr sz="1500" b="0">
                 <a:solidFill>
                   <a:srgbClr val="111111"/>
@@ -13236,6 +13412,7 @@
           <a:lstStyle xmlns:a="http://schemas.openxmlformats.org/drawingml/2006/main"/>
           <a:p xmlns:a="http://schemas.openxmlformats.org/drawingml/2006/main">
             <a:pPr algn="l">
+              <a:buNone/>
               <a:defRPr sz="1500" b="0">
                 <a:solidFill>
                   <a:srgbClr val="111111"/>
@@ -13325,6 +13502,7 @@
           <a:lstStyle xmlns:a="http://schemas.openxmlformats.org/drawingml/2006/main"/>
           <a:p xmlns:a="http://schemas.openxmlformats.org/drawingml/2006/main">
             <a:pPr algn="l">
+              <a:buNone/>
               <a:defRPr sz="1500" b="0">
                 <a:solidFill>
                   <a:srgbClr val="111111"/>
@@ -13414,6 +13592,7 @@
           <a:lstStyle xmlns:a="http://schemas.openxmlformats.org/drawingml/2006/main"/>
           <a:p xmlns:a="http://schemas.openxmlformats.org/drawingml/2006/main">
             <a:pPr algn="l">
+              <a:buNone/>
               <a:defRPr sz="1500" b="0">
                 <a:solidFill>
                   <a:srgbClr val="111111"/>
@@ -13503,6 +13682,7 @@
           <a:lstStyle xmlns:a="http://schemas.openxmlformats.org/drawingml/2006/main"/>
           <a:p xmlns:a="http://schemas.openxmlformats.org/drawingml/2006/main">
             <a:pPr algn="l">
+              <a:buNone/>
               <a:defRPr sz="1500" b="0">
                 <a:solidFill>
                   <a:srgbClr val="111111"/>
@@ -13561,6 +13741,7 @@
           <a:lstStyle xmlns:a="http://schemas.openxmlformats.org/drawingml/2006/main"/>
           <a:p xmlns:a="http://schemas.openxmlformats.org/drawingml/2006/main">
             <a:pPr algn="l">
+              <a:buNone/>
               <a:defRPr sz="1875" b="1">
                 <a:solidFill>
                   <a:srgbClr val="111111"/>

</xml_diff>

<commit_message>
docs(presentation): clarify manual page checks
</commit_message>
<xml_diff>
--- a/docs/EOL_Tracker_Project_Overview.pptx
+++ b/docs/EOL_Tracker_Project_Overview.pptx
@@ -2,22 +2,22 @@
 <file path=ppt/presentation.xml><?xml version="1.0" encoding="utf-8"?>
 <p:presentation xmlns:p="http://schemas.openxmlformats.org/presentationml/2006/main">
   <p:sldMasterIdLst>
-    <p:sldMasterId xmlns:r="http://schemas.openxmlformats.org/officeDocument/2006/relationships" id="2147483648" r:id="R825b90dd868c4766"/>
+    <p:sldMasterId xmlns:r="http://schemas.openxmlformats.org/officeDocument/2006/relationships" id="2147483648" r:id="Red3d9248634746b1"/>
   </p:sldMasterIdLst>
   <p:notesMasterIdLst>
-    <p:notesMasterId xmlns:r="http://schemas.openxmlformats.org/officeDocument/2006/relationships" r:id="R64d41fed89724688"/>
+    <p:notesMasterId xmlns:r="http://schemas.openxmlformats.org/officeDocument/2006/relationships" r:id="R56ed2f71c0464c73"/>
   </p:notesMasterIdLst>
   <p:sldIdLst>
-    <p:sldId xmlns:r="http://schemas.openxmlformats.org/officeDocument/2006/relationships" id="256" r:id="R14b1f9ea3a104c2c"/>
-    <p:sldId xmlns:r="http://schemas.openxmlformats.org/officeDocument/2006/relationships" id="257" r:id="Rb2d70784b6b64aa9"/>
-    <p:sldId xmlns:r="http://schemas.openxmlformats.org/officeDocument/2006/relationships" id="258" r:id="Re00cc89c983f4e7e"/>
-    <p:sldId xmlns:r="http://schemas.openxmlformats.org/officeDocument/2006/relationships" id="259" r:id="Rdb10d187c53a49a7"/>
-    <p:sldId xmlns:r="http://schemas.openxmlformats.org/officeDocument/2006/relationships" id="260" r:id="R161238ca484248ca"/>
-    <p:sldId xmlns:r="http://schemas.openxmlformats.org/officeDocument/2006/relationships" id="261" r:id="R282ddf652c0b4de6"/>
-    <p:sldId xmlns:r="http://schemas.openxmlformats.org/officeDocument/2006/relationships" id="262" r:id="Rd690d3d316a94d9d"/>
-    <p:sldId xmlns:r="http://schemas.openxmlformats.org/officeDocument/2006/relationships" id="263" r:id="R77539b0fd1ce4089"/>
-    <p:sldId xmlns:r="http://schemas.openxmlformats.org/officeDocument/2006/relationships" id="264" r:id="Rbb3422b700fe43d2"/>
-    <p:sldId xmlns:r="http://schemas.openxmlformats.org/officeDocument/2006/relationships" id="265" r:id="Rc305d91ebc0d4bba"/>
+    <p:sldId xmlns:r="http://schemas.openxmlformats.org/officeDocument/2006/relationships" id="256" r:id="Rc2fb1def94bc4155"/>
+    <p:sldId xmlns:r="http://schemas.openxmlformats.org/officeDocument/2006/relationships" id="257" r:id="Ra92309b4e9234942"/>
+    <p:sldId xmlns:r="http://schemas.openxmlformats.org/officeDocument/2006/relationships" id="258" r:id="Ra7242719cff34266"/>
+    <p:sldId xmlns:r="http://schemas.openxmlformats.org/officeDocument/2006/relationships" id="259" r:id="R0adabd3bd31949fe"/>
+    <p:sldId xmlns:r="http://schemas.openxmlformats.org/officeDocument/2006/relationships" id="260" r:id="R74f7f9af4137475c"/>
+    <p:sldId xmlns:r="http://schemas.openxmlformats.org/officeDocument/2006/relationships" id="261" r:id="R6cbebe2b80464093"/>
+    <p:sldId xmlns:r="http://schemas.openxmlformats.org/officeDocument/2006/relationships" id="262" r:id="R806dcf0952f94331"/>
+    <p:sldId xmlns:r="http://schemas.openxmlformats.org/officeDocument/2006/relationships" id="263" r:id="Reaf9af7719b44547"/>
+    <p:sldId xmlns:r="http://schemas.openxmlformats.org/officeDocument/2006/relationships" id="264" r:id="R8e0e3df853044015"/>
+    <p:sldId xmlns:r="http://schemas.openxmlformats.org/officeDocument/2006/relationships" id="265" r:id="R591b13705f6b435e"/>
   </p:sldIdLst>
   <p:sldSz cx="12192000" cy="6858000"/>
   <p:notesSz cx="6858000" cy="9144000"/>
@@ -1424,7 +1424,7 @@
   </p:cSld>
   <p:clrMap bg1="lt1" tx1="dk1" bg2="lt2" tx2="dk2" accent1="accent1" accent2="accent2" accent3="accent3" accent4="accent4" accent5="accent5" accent6="accent6" hlink="hlink" folHlink="folHlink"/>
   <p:sldLayoutIdLst>
-    <p:sldLayoutId xmlns:r="http://schemas.openxmlformats.org/officeDocument/2006/relationships" id="2147483649" r:id="R0ba959bda8a74862"/>
+    <p:sldLayoutId xmlns:r="http://schemas.openxmlformats.org/officeDocument/2006/relationships" id="2147483649" r:id="R82100f773e564958"/>
   </p:sldLayoutIdLst>
   <p:txStyles>
     <p:titleStyle>
@@ -4157,7 +4157,7 @@
                 <a:ea typeface="Arial"/>
                 <a:cs typeface="Arial"/>
               </a:rPr>
-              <a:t>Coverage depends on who remembers what to check</a:t>
+              <a:t>Manual process: navigate to each source page and check it individually</a:t>
             </a:r>
           </a:p>
         </p:txBody>

</xml_diff>